<commit_message>
Agrega guía paso a paso para armar las soluciones en FluidSIM
Nuevo documento docente/RGIM_Guia_FluidSim_Paso_a_Paso.docx: procedimiento base
(insertar componentes, configurar válvulas con doble clic, posición inicial, uniones en T,
marcas de final de carrera con regla de distancia o etiquetas del cilindro, simular y
diagrama de estado), tabla de problemas frecuentes y, para cada uno de los 5 ejercicios,
componentes con su configuración, marcas, conexiones en orden, prueba fase por fase y
qué revisar si no funciona. Los nombres de menú se basan en manuales de FluidSIM 3.6, 4.2
y 6 y pueden variar según la versión.

Co-Authored-By: Claude Opus 5.5 <noreply@anthropic.com>
Claude-Session: https://claude.ai/code/session_016KmDAtWx8UnjEpaRPWkr7o
</commit_message>
<xml_diff>
--- a/sesion1_teoria/RGIM_S1_Representacion_Neumatica_Teoria.pptx
+++ b/sesion1_teoria/RGIM_S1_Representacion_Neumatica_Teoria.pptx
@@ -13337,7 +13337,7 @@
         <p:txBody>
           <a:bodyPr/>
           <a:p>
-            <a:fld id="{E6B4DE7C-0307-4AF8-ACA3-2047746792CD}" type="slidenum">
+            <a:fld id="{913036F5-E056-4D9E-A2EE-69BFC54ECADD}" type="slidenum">
               <a:rPr lang="es-PE"/>
               <a:t>10</a:t>
             </a:fld>
@@ -14137,7 +14137,7 @@
         <p:txBody>
           <a:bodyPr/>
           <a:p>
-            <a:fld id="{65683ED4-4C5B-4499-9310-E8D0ABB7DF13}" type="slidenum">
+            <a:fld id="{CA2FB9D6-2557-4BDD-B738-E65A8F874858}" type="slidenum">
               <a:rPr lang="es-PE"/>
               <a:t>11</a:t>
             </a:fld>
@@ -14453,7 +14453,7 @@
         <p:txBody>
           <a:bodyPr/>
           <a:p>
-            <a:fld id="{9ADD012B-0951-49D5-8581-287E97442BD5}" type="slidenum">
+            <a:fld id="{A2C7CC92-4C51-4E5B-B54D-651A4B42A6EC}" type="slidenum">
               <a:rPr lang="es-PE"/>
               <a:t>12</a:t>
             </a:fld>
@@ -15033,7 +15033,7 @@
         <p:txBody>
           <a:bodyPr/>
           <a:p>
-            <a:fld id="{A2F13FFB-AA11-4337-AB53-834E86D28F92}" type="slidenum">
+            <a:fld id="{D298DF31-98DB-4D7C-AD63-DE787869B82A}" type="slidenum">
               <a:rPr lang="es-PE"/>
               <a:t>14</a:t>
             </a:fld>
@@ -15743,7 +15743,7 @@
         <p:txBody>
           <a:bodyPr/>
           <a:p>
-            <a:fld id="{DEE76094-A075-49B7-A470-3C158A8E7C8E}" type="slidenum">
+            <a:fld id="{402680BD-B3DF-4354-A513-7C3682CB23E6}" type="slidenum">
               <a:rPr lang="es-PE"/>
               <a:t>15</a:t>
             </a:fld>
@@ -15937,7 +15937,7 @@
         <p:txBody>
           <a:bodyPr/>
           <a:p>
-            <a:fld id="{BB20E370-AA62-4448-B35D-60277E25CA85}" type="slidenum">
+            <a:fld id="{FEE2FCCE-18A4-4A9F-9DBD-A4A4EA9FBBF6}" type="slidenum">
               <a:rPr lang="es-PE"/>
               <a:t>16</a:t>
             </a:fld>
@@ -16212,7 +16212,7 @@
         <p:txBody>
           <a:bodyPr/>
           <a:p>
-            <a:fld id="{278572BE-683F-40DF-8792-503802DA6F3A}" type="slidenum">
+            <a:fld id="{6613B856-211E-42DC-851B-331C22BAA641}" type="slidenum">
               <a:rPr lang="es-PE"/>
               <a:t>17</a:t>
             </a:fld>
@@ -16468,7 +16468,7 @@
         <p:txBody>
           <a:bodyPr/>
           <a:p>
-            <a:fld id="{3281B481-B26A-467A-AADD-DE52D68FD022}" type="slidenum">
+            <a:fld id="{424314C3-FFD6-49AA-87B9-731F54A76670}" type="slidenum">
               <a:rPr lang="es-PE"/>
               <a:t>18</a:t>
             </a:fld>
@@ -16759,7 +16759,7 @@
         <p:txBody>
           <a:bodyPr/>
           <a:p>
-            <a:fld id="{3C1F70CA-ABB3-435D-889B-7A1C8F6410B1}" type="slidenum">
+            <a:fld id="{5F77CCD2-6C87-48AE-B509-657A3E374173}" type="slidenum">
               <a:rPr lang="es-PE"/>
               <a:t>19</a:t>
             </a:fld>
@@ -17206,7 +17206,7 @@
         <p:txBody>
           <a:bodyPr/>
           <a:p>
-            <a:fld id="{23681A60-E2B3-438A-880A-2C75C18BD3A5}" type="slidenum">
+            <a:fld id="{01EA2327-193F-4AE5-87BB-2359D246658A}" type="slidenum">
               <a:rPr lang="es-PE"/>
               <a:t>21</a:t>
             </a:fld>
@@ -17500,7 +17500,7 @@
         <p:txBody>
           <a:bodyPr/>
           <a:p>
-            <a:fld id="{36EC3B04-2694-46CC-A92F-ADD9283F957C}" type="slidenum">
+            <a:fld id="{7D97D33E-BC74-47A5-8ACE-EE41300271E1}" type="slidenum">
               <a:rPr lang="es-PE"/>
               <a:t>22</a:t>
             </a:fld>
@@ -17984,7 +17984,7 @@
         <p:txBody>
           <a:bodyPr/>
           <a:p>
-            <a:fld id="{003D7675-D96C-483E-85C6-C62CA96CFA1F}" type="slidenum">
+            <a:fld id="{16B34CA1-9FEA-4AB3-814E-E38D75359C1F}" type="slidenum">
               <a:rPr lang="es-PE"/>
               <a:t>23</a:t>
             </a:fld>
@@ -18240,7 +18240,7 @@
         <p:txBody>
           <a:bodyPr/>
           <a:p>
-            <a:fld id="{298893F5-9B65-44F4-9831-581F90BC9B99}" type="slidenum">
+            <a:fld id="{818D49F8-08C5-47F6-839B-642CB9505D0A}" type="slidenum">
               <a:rPr lang="es-PE"/>
               <a:t>24</a:t>
             </a:fld>
@@ -18780,7 +18780,7 @@
         <p:txBody>
           <a:bodyPr/>
           <a:p>
-            <a:fld id="{B76CB56D-553B-44F7-8C43-7EF21C7D69D8}" type="slidenum">
+            <a:fld id="{2F6A6D57-2BFD-4E68-A677-139941E0B420}" type="slidenum">
               <a:rPr lang="es-PE"/>
               <a:t>25</a:t>
             </a:fld>
@@ -19746,7 +19746,7 @@
         <p:txBody>
           <a:bodyPr/>
           <a:p>
-            <a:fld id="{602CA0CC-CBC2-407F-A98C-3F832203A533}" type="slidenum">
+            <a:fld id="{1E991CE9-0EFB-4CAC-9043-1A71D1C553FB}" type="slidenum">
               <a:rPr lang="es-PE"/>
               <a:t>26</a:t>
             </a:fld>
@@ -19946,7 +19946,7 @@
         <p:txBody>
           <a:bodyPr/>
           <a:p>
-            <a:fld id="{148262FE-0F20-4089-AD35-79A067AB49BD}" type="slidenum">
+            <a:fld id="{1D834CDB-EDCA-49ED-B160-9E750BEE139F}" type="slidenum">
               <a:rPr lang="es-PE"/>
               <a:t>27</a:t>
             </a:fld>
@@ -20530,7 +20530,7 @@
         <p:txBody>
           <a:bodyPr/>
           <a:p>
-            <a:fld id="{CE171D62-D3D5-46CA-A95E-108208F0A6D1}" type="slidenum">
+            <a:fld id="{7CA2E931-EA26-4507-AF27-A4974F4CE3A9}" type="slidenum">
               <a:rPr lang="es-PE"/>
               <a:t>28</a:t>
             </a:fld>
@@ -21632,7 +21632,7 @@
         <p:txBody>
           <a:bodyPr/>
           <a:p>
-            <a:fld id="{1A40FE1B-94F7-48F5-81D7-4D274B17CC78}" type="slidenum">
+            <a:fld id="{89E821AA-B8EC-4DAD-BD01-65EAD6C483E7}" type="slidenum">
               <a:rPr lang="es-PE"/>
               <a:t>29</a:t>
             </a:fld>
@@ -22083,7 +22083,7 @@
         <p:txBody>
           <a:bodyPr/>
           <a:p>
-            <a:fld id="{9935A6F8-07BF-4942-9596-F43248152F9F}" type="slidenum">
+            <a:fld id="{4A79D906-4835-4F3A-A3E7-D22C7A57B12D}" type="slidenum">
               <a:rPr lang="es-PE"/>
               <a:t>3</a:t>
             </a:fld>
@@ -23145,7 +23145,7 @@
         <p:txBody>
           <a:bodyPr/>
           <a:p>
-            <a:fld id="{1BB82810-7C6C-4A47-83C0-2AFA42F7D40B}" type="slidenum">
+            <a:fld id="{7420883D-79FB-4921-B38F-7475EE493BE6}" type="slidenum">
               <a:rPr lang="es-PE"/>
               <a:t>4</a:t>
             </a:fld>
@@ -23848,7 +23848,7 @@
         <p:txBody>
           <a:bodyPr/>
           <a:p>
-            <a:fld id="{332654F8-28AC-4733-BDA5-98CBD843A1E1}" type="slidenum">
+            <a:fld id="{7D0DA90B-C920-47F5-A367-FCE56FB1154E}" type="slidenum">
               <a:rPr lang="es-PE"/>
               <a:t>5</a:t>
             </a:fld>
@@ -24868,7 +24868,7 @@
         <p:txBody>
           <a:bodyPr/>
           <a:p>
-            <a:fld id="{B76DBDE9-2A51-497B-932B-6BB199C2EEE0}" type="slidenum">
+            <a:fld id="{69489225-CCDF-4CD8-87FF-D54D9CFA4380}" type="slidenum">
               <a:rPr lang="es-PE"/>
               <a:t>7</a:t>
             </a:fld>
@@ -25222,7 +25222,7 @@
         <p:txBody>
           <a:bodyPr/>
           <a:p>
-            <a:fld id="{43E0C801-D21E-4427-9DA9-3ADE35E822D4}" type="slidenum">
+            <a:fld id="{6F684D30-70D4-4652-A260-B40B18CB203C}" type="slidenum">
               <a:rPr lang="es-PE"/>
               <a:t>8</a:t>
             </a:fld>
@@ -25316,7 +25316,7 @@
         <p:txBody>
           <a:bodyPr/>
           <a:p>
-            <a:fld id="{2C432A47-17A3-4FE7-A555-6E99D3569203}" type="slidenum">
+            <a:fld id="{B064E5F9-4EB9-49AF-BB7E-BDFBF4F06EAF}" type="slidenum">
               <a:rPr lang="es-PE"/>
               <a:t>9</a:t>
             </a:fld>

</xml_diff>